<commit_message>
feat(capacitacion): incorpora el retrato del autor en portada y cierre
El archivo llego con el nombre que le pone WhatsApp, asi que _resolver_foto toma
cualquier imagen de la carpeta de assets cuando la ruta exacta no existe, en vez
de exigir 'autor.png'.

Encuadre elegido comparando recortes en el tamano real de la slide, no en la
vista ampliada: a 1,32" de diametro el rostro no se reconocia, y cerrar el
recorte a 1,4x cortaba la cabeza contra el borde del circulo. La solucion fue
mantener un encuadre suave (zoom 1.15, centro 0.47) y agrandar el circulo de la
portada a 1,55", con el texto centrado verticalmente contra el retrato en lugar
de colgando del borde superior.

El PNG circular intermedio pasa al temporal del sistema: es un derivado y no
debe quedar versionado junto al original.

Co-Authored-By: Claude Opus 5 (1M context) <noreply@anthropic.com>
</commit_message>
<xml_diff>
--- a/docs/capacitacion/Analisis Fundamental - Capacitacion GI.pptx
+++ b/docs/capacitacion/Analisis Fundamental - Capacitacion GI.pptx
@@ -3378,7 +3378,7 @@
         </p:nvSpPr>
         <p:spPr>
           <a:xfrm>
-            <a:off x="658368" y="4681728"/>
+            <a:off x="658368" y="4590288"/>
             <a:ext cx="10874959" cy="12700"/>
           </a:xfrm>
           <a:prstGeom prst="rect">
@@ -3412,15 +3412,39 @@
           <a:p/>
         </p:txBody>
       </p:sp>
-      <p:sp>
-        <p:nvSpPr>
-          <p:cNvPr id="8" name="TextBox 7"/>
+      <p:pic>
+        <p:nvPicPr>
+          <p:cNvPr id="8" name="Picture 7" descr="gi_retrato_WhatsApp Image 2026-07-02 at 20.34.23.png"/>
+          <p:cNvPicPr>
+            <a:picLocks noChangeAspect="1"/>
+          </p:cNvPicPr>
+          <p:nvPr/>
+        </p:nvPicPr>
+        <p:blipFill>
+          <a:blip r:embed="rId2"/>
+          <a:stretch>
+            <a:fillRect/>
+          </a:stretch>
+        </p:blipFill>
+        <p:spPr>
+          <a:xfrm>
+            <a:off x="658368" y="4864608"/>
+            <a:ext cx="1417320" cy="1417320"/>
+          </a:xfrm>
+          <a:prstGeom prst="rect">
+            <a:avLst/>
+          </a:prstGeom>
+        </p:spPr>
+      </p:pic>
+      <p:sp>
+        <p:nvSpPr>
+          <p:cNvPr id="9" name="TextBox 8"/>
           <p:cNvSpPr txBox="1"/>
           <p:nvPr/>
         </p:nvSpPr>
         <p:spPr>
           <a:xfrm>
-            <a:off x="658368" y="5010912"/>
+            <a:off x="2331720" y="5065776"/>
             <a:ext cx="6766560" cy="182880"/>
           </a:xfrm>
           <a:prstGeom prst="rect">
@@ -3453,13 +3477,13 @@
       </p:sp>
       <p:sp>
         <p:nvSpPr>
-          <p:cNvPr id="9" name="TextBox 8"/>
+          <p:cNvPr id="10" name="TextBox 9"/>
           <p:cNvSpPr txBox="1"/>
           <p:nvPr/>
         </p:nvSpPr>
         <p:spPr>
           <a:xfrm>
-            <a:off x="658368" y="5230368"/>
+            <a:off x="2331720" y="5285232"/>
             <a:ext cx="6766560" cy="274320"/>
           </a:xfrm>
           <a:prstGeom prst="rect">
@@ -3492,13 +3516,13 @@
       </p:sp>
       <p:sp>
         <p:nvSpPr>
-          <p:cNvPr id="10" name="TextBox 9"/>
+          <p:cNvPr id="11" name="TextBox 10"/>
           <p:cNvSpPr txBox="1"/>
           <p:nvPr/>
         </p:nvSpPr>
         <p:spPr>
           <a:xfrm>
-            <a:off x="658368" y="5504688"/>
+            <a:off x="2331720" y="5559552"/>
             <a:ext cx="6766560" cy="201168"/>
           </a:xfrm>
           <a:prstGeom prst="rect">
@@ -3531,13 +3555,13 @@
       </p:sp>
       <p:sp>
         <p:nvSpPr>
-          <p:cNvPr id="11" name="TextBox 10"/>
+          <p:cNvPr id="12" name="TextBox 11"/>
           <p:cNvSpPr txBox="1"/>
           <p:nvPr/>
         </p:nvSpPr>
         <p:spPr>
           <a:xfrm>
-            <a:off x="658368" y="5696712"/>
+            <a:off x="2331720" y="5751576"/>
             <a:ext cx="6766560" cy="201168"/>
           </a:xfrm>
           <a:prstGeom prst="rect">
@@ -3570,13 +3594,13 @@
       </p:sp>
       <p:sp>
         <p:nvSpPr>
-          <p:cNvPr id="12" name="TextBox 11"/>
+          <p:cNvPr id="13" name="TextBox 12"/>
           <p:cNvSpPr txBox="1"/>
           <p:nvPr/>
         </p:nvSpPr>
         <p:spPr>
           <a:xfrm>
-            <a:off x="658368" y="5888736"/>
+            <a:off x="2331720" y="5943600"/>
             <a:ext cx="6766560" cy="201168"/>
           </a:xfrm>
           <a:prstGeom prst="rect">
@@ -3609,13 +3633,13 @@
       </p:sp>
       <p:sp>
         <p:nvSpPr>
-          <p:cNvPr id="13" name="TextBox 12"/>
+          <p:cNvPr id="14" name="TextBox 13"/>
           <p:cNvSpPr txBox="1"/>
           <p:nvPr/>
         </p:nvSpPr>
         <p:spPr>
           <a:xfrm>
-            <a:off x="9208008" y="5010912"/>
+            <a:off x="9208008" y="5065776"/>
             <a:ext cx="2377440" cy="182880"/>
           </a:xfrm>
           <a:prstGeom prst="rect">
@@ -3648,13 +3672,13 @@
       </p:sp>
       <p:sp>
         <p:nvSpPr>
-          <p:cNvPr id="14" name="TextBox 13"/>
+          <p:cNvPr id="15" name="TextBox 14"/>
           <p:cNvSpPr txBox="1"/>
           <p:nvPr/>
         </p:nvSpPr>
         <p:spPr>
           <a:xfrm>
-            <a:off x="9208008" y="5212080"/>
+            <a:off x="9208008" y="5266944"/>
             <a:ext cx="2377440" cy="237744"/>
           </a:xfrm>
           <a:prstGeom prst="rect">
@@ -3687,13 +3711,13 @@
       </p:sp>
       <p:sp>
         <p:nvSpPr>
-          <p:cNvPr id="15" name="TextBox 14"/>
+          <p:cNvPr id="16" name="TextBox 15"/>
           <p:cNvSpPr txBox="1"/>
           <p:nvPr/>
         </p:nvSpPr>
         <p:spPr>
           <a:xfrm>
-            <a:off x="9208008" y="5577840"/>
+            <a:off x="9208008" y="5632704"/>
             <a:ext cx="2377440" cy="182880"/>
           </a:xfrm>
           <a:prstGeom prst="rect">
@@ -3726,13 +3750,13 @@
       </p:sp>
       <p:sp>
         <p:nvSpPr>
-          <p:cNvPr id="16" name="TextBox 15"/>
+          <p:cNvPr id="17" name="TextBox 16"/>
           <p:cNvSpPr txBox="1"/>
           <p:nvPr/>
         </p:nvSpPr>
         <p:spPr>
           <a:xfrm>
-            <a:off x="9208008" y="5779008"/>
+            <a:off x="9208008" y="5833872"/>
             <a:ext cx="2377440" cy="237744"/>
           </a:xfrm>
           <a:prstGeom prst="rect">
@@ -60193,15 +60217,39 @@
           </a:p>
         </p:txBody>
       </p:sp>
-      <p:sp>
-        <p:nvSpPr>
-          <p:cNvPr id="13" name="TextBox 12"/>
+      <p:pic>
+        <p:nvPicPr>
+          <p:cNvPr id="13" name="Picture 12" descr="gi_retrato_WhatsApp Image 2026-07-02 at 20.34.23.png"/>
+          <p:cNvPicPr>
+            <a:picLocks noChangeAspect="1"/>
+          </p:cNvPicPr>
+          <p:nvPr/>
+        </p:nvPicPr>
+        <p:blipFill>
+          <a:blip r:embed="rId2"/>
+          <a:stretch>
+            <a:fillRect/>
+          </a:stretch>
+        </p:blipFill>
+        <p:spPr>
+          <a:xfrm>
+            <a:off x="658368" y="5394960"/>
+            <a:ext cx="932688" cy="932688"/>
+          </a:xfrm>
+          <a:prstGeom prst="rect">
+            <a:avLst/>
+          </a:prstGeom>
+        </p:spPr>
+      </p:pic>
+      <p:sp>
+        <p:nvSpPr>
+          <p:cNvPr id="14" name="TextBox 13"/>
           <p:cNvSpPr txBox="1"/>
           <p:nvPr/>
         </p:nvSpPr>
         <p:spPr>
           <a:xfrm>
-            <a:off x="658368" y="5449824"/>
+            <a:off x="1847088" y="5449824"/>
             <a:ext cx="6766560" cy="182880"/>
           </a:xfrm>
           <a:prstGeom prst="rect">
@@ -60234,13 +60282,13 @@
       </p:sp>
       <p:sp>
         <p:nvSpPr>
-          <p:cNvPr id="14" name="TextBox 13"/>
+          <p:cNvPr id="15" name="TextBox 14"/>
           <p:cNvSpPr txBox="1"/>
           <p:nvPr/>
         </p:nvSpPr>
         <p:spPr>
           <a:xfrm>
-            <a:off x="658368" y="5669280"/>
+            <a:off x="1847088" y="5669280"/>
             <a:ext cx="6766560" cy="274320"/>
           </a:xfrm>
           <a:prstGeom prst="rect">
@@ -60273,13 +60321,13 @@
       </p:sp>
       <p:sp>
         <p:nvSpPr>
-          <p:cNvPr id="15" name="TextBox 14"/>
+          <p:cNvPr id="16" name="TextBox 15"/>
           <p:cNvSpPr txBox="1"/>
           <p:nvPr/>
         </p:nvSpPr>
         <p:spPr>
           <a:xfrm>
-            <a:off x="658368" y="5943600"/>
+            <a:off x="1847088" y="5943600"/>
             <a:ext cx="6766560" cy="201168"/>
           </a:xfrm>
           <a:prstGeom prst="rect">
@@ -60312,13 +60360,13 @@
       </p:sp>
       <p:sp>
         <p:nvSpPr>
-          <p:cNvPr id="16" name="TextBox 15"/>
+          <p:cNvPr id="17" name="TextBox 16"/>
           <p:cNvSpPr txBox="1"/>
           <p:nvPr/>
         </p:nvSpPr>
         <p:spPr>
           <a:xfrm>
-            <a:off x="658368" y="6135624"/>
+            <a:off x="1847088" y="6135624"/>
             <a:ext cx="6766560" cy="201168"/>
           </a:xfrm>
           <a:prstGeom prst="rect">
@@ -60351,7 +60399,7 @@
       </p:sp>
       <p:sp>
         <p:nvSpPr>
-          <p:cNvPr id="17" name="TextBox 16"/>
+          <p:cNvPr id="18" name="TextBox 17"/>
           <p:cNvSpPr txBox="1"/>
           <p:nvPr/>
         </p:nvSpPr>

</xml_diff>

<commit_message>
feat(capacitacion): retrato y autoria del director en la guia rapida
La guia queda firmada igual que la presentacion: retrato circular y credenciales
en la cabecera de la primera hoja y junto al cierre de la ultima.

En la cabecera va a la derecha del titulo, no debajo: ocupa ancho y no alto, y
las hojas estan calibradas al milimetro contra el alto de una A4 —cualquier
bloque nuevo en vertical habria partido la pagina en dos—.

El recorte circular se extrae a scripts/retrato.py, compartido por los dos
generadores. El folleto no puede importarlo del modulo del PPTX sin arrastrar
python-pptx, que no esta en el entorno del proyecto.

El retrato se incrusta en WebP y no en PNG: con transparencia el PNG dejaba el
HTML autonomo en 982 KB, inservible como adjunto de mensajeria. En WebP el
retrato pesa 24 KB y el archivo completo 224 KB.

Co-Authored-By: Claude Opus 5 (1M context) <noreply@anthropic.com>
</commit_message>
<xml_diff>
--- a/docs/capacitacion/Analisis Fundamental - Capacitacion GI.pptx
+++ b/docs/capacitacion/Analisis Fundamental - Capacitacion GI.pptx
@@ -3414,7 +3414,7 @@
       </p:sp>
       <p:pic>
         <p:nvPicPr>
-          <p:cNvPr id="8" name="Picture 7" descr="gi_retrato_WhatsApp Image 2026-07-02 at 20.34.23.png"/>
+          <p:cNvPr id="8" name="Picture 7" descr="gi_retrato_WhatsApp Image 2026-07-02 at 20.34.23_720.png"/>
           <p:cNvPicPr>
             <a:picLocks noChangeAspect="1"/>
           </p:cNvPicPr>
@@ -60219,7 +60219,7 @@
       </p:sp>
       <p:pic>
         <p:nvPicPr>
-          <p:cNvPr id="13" name="Picture 12" descr="gi_retrato_WhatsApp Image 2026-07-02 at 20.34.23.png"/>
+          <p:cNvPr id="13" name="Picture 12" descr="gi_retrato_WhatsApp Image 2026-07-02 at 20.34.23_720.png"/>
           <p:cNvPicPr>
             <a:picLocks noChangeAspect="1"/>
           </p:cNvPicPr>

</xml_diff>